<commit_message>
Rebuild slide 01 pptx from updated prompts
</commit_message>
<xml_diff>
--- a/PPT-last/single_slides/slide_01.pptx
+++ b/PPT-last/single_slides/slide_01.pptx
@@ -3138,14 +3138,14 @@
       </p:pic>
       <p:pic>
         <p:nvPicPr>
-          <p:cNvPr id="4" name="Picture 3" descr="deco_props.png"/>
+          <p:cNvPr id="4" name="Picture 3" descr="deco_border.png"/>
           <p:cNvPicPr>
             <a:picLocks noChangeAspect="1"/>
           </p:cNvPicPr>
           <p:nvPr/>
         </p:nvPicPr>
         <p:blipFill>
-          <a:blip r:embed="rId4"/>
+          <a:blip r:embed="rId3"/>
           <a:stretch>
             <a:fillRect/>
           </a:stretch>
@@ -3162,14 +3162,14 @@
       </p:pic>
       <p:pic>
         <p:nvPicPr>
-          <p:cNvPr id="5" name="Picture 4" descr="figure.png"/>
+          <p:cNvPr id="5" name="Picture 4" descr="deco_border.png"/>
           <p:cNvPicPr>
             <a:picLocks noChangeAspect="1"/>
           </p:cNvPicPr>
           <p:nvPr/>
         </p:nvPicPr>
         <p:blipFill>
-          <a:blip r:embed="rId5"/>
+          <a:blip r:embed="rId3"/>
           <a:stretch>
             <a:fillRect/>
           </a:stretch>
@@ -3186,14 +3186,14 @@
       </p:pic>
       <p:pic>
         <p:nvPicPr>
-          <p:cNvPr id="6" name="Picture 5" descr="infograph.png"/>
+          <p:cNvPr id="6" name="Picture 5" descr="deco_border.png"/>
           <p:cNvPicPr>
             <a:picLocks noChangeAspect="1"/>
           </p:cNvPicPr>
           <p:nvPr/>
         </p:nvPicPr>
         <p:blipFill>
-          <a:blip r:embed="rId6"/>
+          <a:blip r:embed="rId3"/>
           <a:stretch>
             <a:fillRect/>
           </a:stretch>
@@ -3210,14 +3210,14 @@
       </p:pic>
       <p:pic>
         <p:nvPicPr>
-          <p:cNvPr id="7" name="Picture 6" descr="art_title.png"/>
+          <p:cNvPr id="7" name="Picture 6" descr="deco_border.png"/>
           <p:cNvPicPr>
             <a:picLocks noChangeAspect="1"/>
           </p:cNvPicPr>
           <p:nvPr/>
         </p:nvPicPr>
         <p:blipFill>
-          <a:blip r:embed="rId7"/>
+          <a:blip r:embed="rId3"/>
           <a:stretch>
             <a:fillRect/>
           </a:stretch>
@@ -3241,7 +3241,7 @@
           <p:nvPr/>
         </p:nvPicPr>
         <p:blipFill>
-          <a:blip r:embed="rId8"/>
+          <a:blip r:embed="rId4"/>
           <a:stretch>
             <a:fillRect/>
           </a:stretch>
@@ -3264,8 +3264,8 @@
         </p:nvSpPr>
         <p:spPr>
           <a:xfrm>
-            <a:off x="2857500" y="700087"/>
-            <a:ext cx="3405187" cy="238125"/>
+            <a:off x="2857500" y="704850"/>
+            <a:ext cx="3405187" cy="200025"/>
           </a:xfrm>
           <a:prstGeom prst="rect">
             <a:avLst/>
@@ -3280,7 +3280,7 @@
           <a:p>
             <a:pPr algn="ctr"/>
             <a:r>
-              <a:rPr a:ea="微软雅黑" sz="2800">
+              <a:rPr a:ea="微软雅黑" sz="2100">
                 <a:solidFill>
                   <a:srgbClr val="2F372B"/>
                 </a:solidFill>
@@ -3299,8 +3299,8 @@
         </p:nvSpPr>
         <p:spPr>
           <a:xfrm>
-            <a:off x="2762250" y="2667000"/>
-            <a:ext cx="3619500" cy="247650"/>
+            <a:off x="3071812" y="2390775"/>
+            <a:ext cx="3095625" cy="200025"/>
           </a:xfrm>
           <a:prstGeom prst="rect">
             <a:avLst/>
@@ -3315,7 +3315,7 @@
           <a:p>
             <a:pPr algn="ctr"/>
             <a:r>
-              <a:rPr a:ea="微软雅黑" sz="2800">
+              <a:rPr a:ea="微软雅黑" sz="2200">
                 <a:solidFill>
                   <a:srgbClr val="2D6A45"/>
                 </a:solidFill>
@@ -3334,8 +3334,8 @@
         </p:nvSpPr>
         <p:spPr>
           <a:xfrm>
-            <a:off x="3152775" y="2952750"/>
-            <a:ext cx="2857500" cy="200025"/>
+            <a:off x="3119437" y="2657475"/>
+            <a:ext cx="2952750" cy="180975"/>
           </a:xfrm>
           <a:prstGeom prst="rect">
             <a:avLst/>
@@ -3350,7 +3350,7 @@
           <a:p>
             <a:pPr algn="ctr"/>
             <a:r>
-              <a:rPr a:ea="宋体" sz="2400">
+              <a:rPr a:ea="宋体" sz="2000">
                 <a:solidFill>
                   <a:srgbClr val="2F372B"/>
                 </a:solidFill>
@@ -3369,8 +3369,8 @@
         </p:nvSpPr>
         <p:spPr>
           <a:xfrm>
-            <a:off x="3095625" y="3700462"/>
-            <a:ext cx="285750" cy="190500"/>
+            <a:off x="3095625" y="3457575"/>
+            <a:ext cx="285750" cy="180975"/>
           </a:xfrm>
           <a:prstGeom prst="rect">
             <a:avLst/>
@@ -3385,7 +3385,7 @@
           <a:p>
             <a:pPr algn="ctr"/>
             <a:r>
-              <a:rPr a:ea="微软雅黑" sz="2600">
+              <a:rPr a:ea="微软雅黑" sz="2400">
                 <a:solidFill>
                   <a:srgbClr val="2F372B"/>
                 </a:solidFill>
@@ -3404,8 +3404,8 @@
         </p:nvSpPr>
         <p:spPr>
           <a:xfrm>
-            <a:off x="3952875" y="3700462"/>
-            <a:ext cx="285750" cy="190500"/>
+            <a:off x="3952875" y="3457575"/>
+            <a:ext cx="285750" cy="180975"/>
           </a:xfrm>
           <a:prstGeom prst="rect">
             <a:avLst/>
@@ -3420,7 +3420,7 @@
           <a:p>
             <a:pPr algn="ctr"/>
             <a:r>
-              <a:rPr a:ea="微软雅黑" sz="2600">
+              <a:rPr a:ea="微软雅黑" sz="2400">
                 <a:solidFill>
                   <a:srgbClr val="2F372B"/>
                 </a:solidFill>
@@ -3439,8 +3439,8 @@
         </p:nvSpPr>
         <p:spPr>
           <a:xfrm>
-            <a:off x="4810125" y="3700462"/>
-            <a:ext cx="285750" cy="190500"/>
+            <a:off x="4810125" y="3457575"/>
+            <a:ext cx="285750" cy="180975"/>
           </a:xfrm>
           <a:prstGeom prst="rect">
             <a:avLst/>
@@ -3455,7 +3455,7 @@
           <a:p>
             <a:pPr algn="ctr"/>
             <a:r>
-              <a:rPr a:ea="微软雅黑" sz="2600">
+              <a:rPr a:ea="微软雅黑" sz="2400">
                 <a:solidFill>
                   <a:srgbClr val="2F372B"/>
                 </a:solidFill>
@@ -3474,8 +3474,8 @@
         </p:nvSpPr>
         <p:spPr>
           <a:xfrm>
-            <a:off x="5667375" y="3700462"/>
-            <a:ext cx="285750" cy="190500"/>
+            <a:off x="5667375" y="3457575"/>
+            <a:ext cx="285750" cy="180975"/>
           </a:xfrm>
           <a:prstGeom prst="rect">
             <a:avLst/>
@@ -3490,7 +3490,7 @@
           <a:p>
             <a:pPr algn="ctr"/>
             <a:r>
-              <a:rPr a:ea="微软雅黑" sz="2600">
+              <a:rPr a:ea="微软雅黑" sz="2400">
                 <a:solidFill>
                   <a:srgbClr val="2F372B"/>
                 </a:solidFill>

</xml_diff>